<commit_message>
docs: update Kickstarter deck, talking points, and video script deliverables
</commit_message>
<xml_diff>
--- a/deliverables/THOX_Kickstarter_Deck.pptx
+++ b/deliverables/THOX_Kickstarter_Deck.pptx
@@ -3300,7 +3300,7 @@
                 </a:solidFill>
                 <a:latin typeface="Arial"/>
               </a:rPr>
-              <a:t>Your AI, on silicon you own.</a:t>
+              <a:t>Your AI. Your Data. Your Rules.</a:t>
             </a:r>
           </a:p>
         </p:txBody>
@@ -3567,7 +3567,7 @@
                 </a:solidFill>
                 <a:latin typeface="Xolonium" panose="02000503000000000000" pitchFamily="2" charset="0"/>
               </a:rPr>
-              <a:t>THOX.ai  Your AI, on silicon you own.</a:t>
+              <a:t>THOX.ai  Your AI. Your Data. Your Rules.</a:t>
             </a:r>
           </a:p>
         </p:txBody>
@@ -4282,7 +4282,7 @@
                 </a:solidFill>
                 <a:latin typeface="Xolonium" panose="02000503000000000000" pitchFamily="2" charset="0"/>
               </a:rPr>
-              <a:t>THOX.ai  Your AI, on silicon you own.</a:t>
+              <a:t>THOX.ai  Your AI. Your Data. Your Rules.</a:t>
             </a:r>
           </a:p>
         </p:txBody>
@@ -6025,7 +6025,7 @@
                 </a:solidFill>
                 <a:latin typeface="Xolonium" panose="02000503000000000000" pitchFamily="2" charset="0"/>
               </a:rPr>
-              <a:t>THOX.ai  Your AI, on silicon you own.</a:t>
+              <a:t>THOX.ai  Your AI. Your Data. Your Rules.</a:t>
             </a:r>
           </a:p>
         </p:txBody>
@@ -6962,7 +6962,7 @@
                 </a:solidFill>
                 <a:latin typeface="Xolonium" panose="02000503000000000000" pitchFamily="2" charset="0"/>
               </a:rPr>
-              <a:t>THOX.ai  Your AI, on silicon you own.</a:t>
+              <a:t>THOX.ai  Your AI. Your Data. Your Rules.</a:t>
             </a:r>
           </a:p>
         </p:txBody>
@@ -7875,7 +7875,7 @@
                 </a:solidFill>
                 <a:latin typeface="Xolonium" panose="02000503000000000000" pitchFamily="2" charset="0"/>
               </a:rPr>
-              <a:t>THOX.ai  Your AI, on silicon you own.</a:t>
+              <a:t>THOX.ai  Your AI. Your Data. Your Rules.</a:t>
             </a:r>
           </a:p>
         </p:txBody>
@@ -8128,7 +8128,7 @@
                 </a:solidFill>
                 <a:latin typeface="Arial"/>
               </a:rPr>
-              <a:t>Your AI, on silicon you own.</a:t>
+              <a:t>Your AI. Your Data. Your Rules.</a:t>
             </a:r>
           </a:p>
         </p:txBody>
@@ -8356,7 +8356,7 @@
                 </a:solidFill>
                 <a:latin typeface="Xolonium" panose="02000503000000000000" pitchFamily="2" charset="0"/>
               </a:rPr>
-              <a:t>THOX.ai  Your AI, on silicon you own.</a:t>
+              <a:t>THOX.ai  Your AI. Your Data. Your Rules.</a:t>
             </a:r>
           </a:p>
         </p:txBody>
@@ -8715,7 +8715,7 @@
                 </a:solidFill>
                 <a:latin typeface="Xolonium" panose="02000503000000000000" pitchFamily="2" charset="0"/>
               </a:rPr>
-              <a:t>THOX.ai  Your AI, on silicon you own.</a:t>
+              <a:t>THOX.ai  Your AI. Your Data. Your Rules.</a:t>
             </a:r>
           </a:p>
         </p:txBody>
@@ -9615,7 +9615,7 @@
                 </a:solidFill>
                 <a:latin typeface="Xolonium" panose="02000503000000000000" pitchFamily="2" charset="0"/>
               </a:rPr>
-              <a:t>THOX.ai  Your AI, on silicon you own.</a:t>
+              <a:t>THOX.ai  Your AI. Your Data. Your Rules.</a:t>
             </a:r>
           </a:p>
         </p:txBody>
@@ -10812,7 +10812,7 @@
                 </a:solidFill>
                 <a:latin typeface="Xolonium" panose="02000503000000000000" pitchFamily="2" charset="0"/>
               </a:rPr>
-              <a:t>THOX.ai  Your AI, on silicon you own.</a:t>
+              <a:t>THOX.ai  Your AI. Your Data. Your Rules.</a:t>
             </a:r>
           </a:p>
         </p:txBody>
@@ -11439,7 +11439,7 @@
                 </a:solidFill>
                 <a:latin typeface="Xolonium" panose="02000503000000000000" pitchFamily="2" charset="0"/>
               </a:rPr>
-              <a:t>THOX.ai  Your AI, on silicon you own.</a:t>
+              <a:t>THOX.ai  Your AI. Your Data. Your Rules.</a:t>
             </a:r>
           </a:p>
         </p:txBody>
@@ -12051,7 +12051,7 @@
                 </a:solidFill>
                 <a:latin typeface="Xolonium" panose="02000503000000000000" pitchFamily="2" charset="0"/>
               </a:rPr>
-              <a:t>THOX.ai  Your AI, on silicon you own.</a:t>
+              <a:t>THOX.ai  Your AI. Your Data. Your Rules.</a:t>
             </a:r>
           </a:p>
         </p:txBody>
@@ -12699,7 +12699,7 @@
                 </a:solidFill>
                 <a:latin typeface="Xolonium" panose="02000503000000000000" pitchFamily="2" charset="0"/>
               </a:rPr>
-              <a:t>THOX.ai  Your AI, on silicon you own.</a:t>
+              <a:t>THOX.ai  Your AI. Your Data. Your Rules.</a:t>
             </a:r>
           </a:p>
         </p:txBody>
@@ -13329,7 +13329,7 @@
                 </a:solidFill>
                 <a:latin typeface="Xolonium" panose="02000503000000000000" pitchFamily="2" charset="0"/>
               </a:rPr>
-              <a:t>THOX.ai  Your AI, on silicon you own.</a:t>
+              <a:t>THOX.ai  Your AI. Your Data. Your Rules.</a:t>
             </a:r>
           </a:p>
         </p:txBody>
@@ -14430,7 +14430,7 @@
                 </a:solidFill>
                 <a:latin typeface="Xolonium" panose="02000503000000000000" pitchFamily="2" charset="0"/>
               </a:rPr>
-              <a:t>THOX.ai  Your AI, on silicon you own.</a:t>
+              <a:t>THOX.ai  Your AI. Your Data. Your Rules.</a:t>
             </a:r>
           </a:p>
         </p:txBody>

</xml_diff>